<commit_message>
improved chat citation and added conversation history citation and though
</commit_message>
<xml_diff>
--- a/artifacts/release_timeline.pptx
+++ b/artifacts/release_timeline.pptx
@@ -196,7 +196,7 @@
           </a:lstStyle>
           <a:p>
             <a:fld id="{112271D8-6539-4EB0-A25C-1B7D13FE909C}" type="datetimeFigureOut">
-              <a:t>4/2/2026</a:t>
+              <a:t>4/3/2026</a:t>
             </a:fld>
             <a:endParaRPr lang="en-US"/>
           </a:p>
@@ -609,7 +609,7 @@
           <a:p>
             <a:fld id="{40617403-03E0-4D0F-839A-15E397C8F9BE}" type="datetimeFigureOut">
               <a:rPr lang="en-US" smtClean="0"/>
-              <a:t>4/2/2026</a:t>
+              <a:t>4/3/2026</a:t>
             </a:fld>
             <a:endParaRPr lang="en-US"/>
           </a:p>
@@ -807,7 +807,7 @@
           <a:p>
             <a:fld id="{40617403-03E0-4D0F-839A-15E397C8F9BE}" type="datetimeFigureOut">
               <a:rPr lang="en-US" smtClean="0"/>
-              <a:t>4/2/2026</a:t>
+              <a:t>4/3/2026</a:t>
             </a:fld>
             <a:endParaRPr lang="en-US"/>
           </a:p>
@@ -1015,7 +1015,7 @@
           <a:p>
             <a:fld id="{40617403-03E0-4D0F-839A-15E397C8F9BE}" type="datetimeFigureOut">
               <a:rPr lang="en-US" smtClean="0"/>
-              <a:t>4/2/2026</a:t>
+              <a:t>4/3/2026</a:t>
             </a:fld>
             <a:endParaRPr lang="en-US"/>
           </a:p>
@@ -1213,7 +1213,7 @@
           <a:p>
             <a:fld id="{40617403-03E0-4D0F-839A-15E397C8F9BE}" type="datetimeFigureOut">
               <a:rPr lang="en-US" smtClean="0"/>
-              <a:t>4/2/2026</a:t>
+              <a:t>4/3/2026</a:t>
             </a:fld>
             <a:endParaRPr lang="en-US"/>
           </a:p>
@@ -1488,7 +1488,7 @@
           <a:p>
             <a:fld id="{40617403-03E0-4D0F-839A-15E397C8F9BE}" type="datetimeFigureOut">
               <a:rPr lang="en-US" smtClean="0"/>
-              <a:t>4/2/2026</a:t>
+              <a:t>4/3/2026</a:t>
             </a:fld>
             <a:endParaRPr lang="en-US"/>
           </a:p>
@@ -1753,7 +1753,7 @@
           <a:p>
             <a:fld id="{40617403-03E0-4D0F-839A-15E397C8F9BE}" type="datetimeFigureOut">
               <a:rPr lang="en-US" smtClean="0"/>
-              <a:t>4/2/2026</a:t>
+              <a:t>4/3/2026</a:t>
             </a:fld>
             <a:endParaRPr lang="en-US"/>
           </a:p>
@@ -2165,7 +2165,7 @@
           <a:p>
             <a:fld id="{40617403-03E0-4D0F-839A-15E397C8F9BE}" type="datetimeFigureOut">
               <a:rPr lang="en-US" smtClean="0"/>
-              <a:t>4/2/2026</a:t>
+              <a:t>4/3/2026</a:t>
             </a:fld>
             <a:endParaRPr lang="en-US"/>
           </a:p>
@@ -2306,7 +2306,7 @@
           <a:p>
             <a:fld id="{40617403-03E0-4D0F-839A-15E397C8F9BE}" type="datetimeFigureOut">
               <a:rPr lang="en-US" smtClean="0"/>
-              <a:t>4/2/2026</a:t>
+              <a:t>4/3/2026</a:t>
             </a:fld>
             <a:endParaRPr lang="en-US"/>
           </a:p>
@@ -2419,7 +2419,7 @@
           <a:p>
             <a:fld id="{40617403-03E0-4D0F-839A-15E397C8F9BE}" type="datetimeFigureOut">
               <a:rPr lang="en-US" smtClean="0"/>
-              <a:t>4/2/2026</a:t>
+              <a:t>4/3/2026</a:t>
             </a:fld>
             <a:endParaRPr lang="en-US"/>
           </a:p>
@@ -2730,7 +2730,7 @@
           <a:p>
             <a:fld id="{40617403-03E0-4D0F-839A-15E397C8F9BE}" type="datetimeFigureOut">
               <a:rPr lang="en-US" smtClean="0"/>
-              <a:t>4/2/2026</a:t>
+              <a:t>4/3/2026</a:t>
             </a:fld>
             <a:endParaRPr lang="en-US"/>
           </a:p>
@@ -3018,7 +3018,7 @@
           <a:p>
             <a:fld id="{40617403-03E0-4D0F-839A-15E397C8F9BE}" type="datetimeFigureOut">
               <a:rPr lang="en-US" smtClean="0"/>
-              <a:t>4/2/2026</a:t>
+              <a:t>4/3/2026</a:t>
             </a:fld>
             <a:endParaRPr lang="en-US"/>
           </a:p>
@@ -3259,7 +3259,7 @@
           <a:p>
             <a:fld id="{40617403-03E0-4D0F-839A-15E397C8F9BE}" type="datetimeFigureOut">
               <a:rPr lang="en-US" smtClean="0"/>
-              <a:t>4/2/2026</a:t>
+              <a:t>4/3/2026</a:t>
             </a:fld>
             <a:endParaRPr lang="en-US"/>
           </a:p>
@@ -4201,7 +4201,7 @@
           <a:p>
             <a:r>
               <a:rPr lang="en-US" sz="1600" dirty="0"/>
-              <a:t>April 3</a:t>
+              <a:t>April 7</a:t>
             </a:r>
           </a:p>
         </p:txBody>
@@ -4236,7 +4236,7 @@
           <a:p>
             <a:r>
               <a:rPr lang="en-US" sz="1600" dirty="0"/>
-              <a:t>April 9</a:t>
+              <a:t>April 16</a:t>
             </a:r>
           </a:p>
         </p:txBody>
@@ -4408,7 +4408,7 @@
           <a:p>
             <a:r>
               <a:rPr lang="en-US" sz="1600" dirty="0"/>
-              <a:t>April 16</a:t>
+              <a:t>April 23</a:t>
             </a:r>
           </a:p>
         </p:txBody>
@@ -4600,7 +4600,7 @@
           <a:p>
             <a:r>
               <a:rPr lang="en-US" sz="1600" dirty="0"/>
-              <a:t>April 23</a:t>
+              <a:t>April 30</a:t>
             </a:r>
           </a:p>
         </p:txBody>
@@ -4718,7 +4718,7 @@
         <p:spPr>
           <a:xfrm>
             <a:off x="7042352" y="5624698"/>
-            <a:ext cx="2108036" cy="1015663"/>
+            <a:ext cx="2108036" cy="1200329"/>
           </a:xfrm>
           <a:prstGeom prst="rect">
             <a:avLst/>
@@ -4737,6 +4737,16 @@
             </a:pPr>
             <a:r>
               <a:rPr lang="en-US" sz="1200" dirty="0"/>
+              <a:t>Google Workspace Sync</a:t>
+            </a:r>
+          </a:p>
+          <a:p>
+            <a:pPr marL="285750" indent="-285750">
+              <a:buFontTx/>
+              <a:buChar char="-"/>
+            </a:pPr>
+            <a:r>
+              <a:rPr lang="en-US" sz="1200" dirty="0"/>
               <a:t>File Share Sync to Workspaces</a:t>
             </a:r>
           </a:p>
@@ -4802,7 +4812,7 @@
           <a:p>
             <a:r>
               <a:rPr lang="en-US" sz="1600" dirty="0"/>
-              <a:t>May 7</a:t>
+              <a:t>May 14</a:t>
             </a:r>
           </a:p>
         </p:txBody>
@@ -4994,7 +5004,7 @@
           <a:p>
             <a:r>
               <a:rPr lang="en-US" sz="1600" dirty="0"/>
-              <a:t>May 14</a:t>
+              <a:t>May 21</a:t>
             </a:r>
           </a:p>
         </p:txBody>
@@ -5186,7 +5196,7 @@
           <a:p>
             <a:r>
               <a:rPr lang="en-US" sz="1600" dirty="0"/>
-              <a:t>May 21</a:t>
+              <a:t>May 28</a:t>
             </a:r>
           </a:p>
         </p:txBody>
@@ -5358,7 +5368,7 @@
           <a:p>
             <a:r>
               <a:rPr lang="en-US" sz="1600" dirty="0"/>
-              <a:t>June 4</a:t>
+              <a:t>June 11</a:t>
             </a:r>
           </a:p>
         </p:txBody>

</xml_diff>